<commit_message>
docs: index DSH plugin research sources
</commit_message>
<xml_diff>
--- a/talk-ai-coding-evolution/05_output/v6/OPC航海指南-harness-v6.pptx
+++ b/talk-ai-coding-evolution/05_output/v6/OPC航海指南-harness-v6.pptx
@@ -2,35 +2,35 @@
 <file path=ppt/presentation.xml><?xml version="1.0" encoding="utf-8"?>
 <p:presentation xmlns:p="http://schemas.openxmlformats.org/presentationml/2006/main">
   <p:sldMasterIdLst>
-    <p:sldMasterId xmlns:r="http://schemas.openxmlformats.org/officeDocument/2006/relationships" id="2147483648" r:id="Rab6703c641a34455"/>
+    <p:sldMasterId xmlns:r="http://schemas.openxmlformats.org/officeDocument/2006/relationships" id="2147483648" r:id="Re1801c94860a44ea"/>
   </p:sldMasterIdLst>
   <p:notesMasterIdLst>
-    <p:notesMasterId xmlns:r="http://schemas.openxmlformats.org/officeDocument/2006/relationships" r:id="R6d402c46b4cb492d"/>
+    <p:notesMasterId xmlns:r="http://schemas.openxmlformats.org/officeDocument/2006/relationships" r:id="R61238c6f586145b4"/>
   </p:notesMasterIdLst>
   <p:sldIdLst>
-    <p:sldId xmlns:r="http://schemas.openxmlformats.org/officeDocument/2006/relationships" id="256" r:id="R20e11901e336459d"/>
-    <p:sldId xmlns:r="http://schemas.openxmlformats.org/officeDocument/2006/relationships" id="257" r:id="R28dc9f5bd10d48d6"/>
-    <p:sldId xmlns:r="http://schemas.openxmlformats.org/officeDocument/2006/relationships" id="258" r:id="R91ea349d9af244a5"/>
-    <p:sldId xmlns:r="http://schemas.openxmlformats.org/officeDocument/2006/relationships" id="259" r:id="Rfefd0d5460ee4cbe"/>
-    <p:sldId xmlns:r="http://schemas.openxmlformats.org/officeDocument/2006/relationships" id="260" r:id="R68cf8f2b3bd64457"/>
-    <p:sldId xmlns:r="http://schemas.openxmlformats.org/officeDocument/2006/relationships" id="261" r:id="Rec2f5d77e3294498"/>
-    <p:sldId xmlns:r="http://schemas.openxmlformats.org/officeDocument/2006/relationships" id="262" r:id="R84a34e92ba6b48e7"/>
-    <p:sldId xmlns:r="http://schemas.openxmlformats.org/officeDocument/2006/relationships" id="263" r:id="Racda5a07df68416b"/>
-    <p:sldId xmlns:r="http://schemas.openxmlformats.org/officeDocument/2006/relationships" id="264" r:id="R48aaa5c850514c9e"/>
-    <p:sldId xmlns:r="http://schemas.openxmlformats.org/officeDocument/2006/relationships" id="265" r:id="R3dabee007f8c468a"/>
-    <p:sldId xmlns:r="http://schemas.openxmlformats.org/officeDocument/2006/relationships" id="266" r:id="R531a30739951478c"/>
-    <p:sldId xmlns:r="http://schemas.openxmlformats.org/officeDocument/2006/relationships" id="267" r:id="Rc37b72b7d91445b3"/>
-    <p:sldId xmlns:r="http://schemas.openxmlformats.org/officeDocument/2006/relationships" id="268" r:id="R4f019f4efd7a4fef"/>
-    <p:sldId xmlns:r="http://schemas.openxmlformats.org/officeDocument/2006/relationships" id="269" r:id="Ra17365cce1f6460c"/>
-    <p:sldId xmlns:r="http://schemas.openxmlformats.org/officeDocument/2006/relationships" id="270" r:id="Rb73c2f4f417e4c49"/>
-    <p:sldId xmlns:r="http://schemas.openxmlformats.org/officeDocument/2006/relationships" id="271" r:id="R164bd6020e204a6a"/>
-    <p:sldId xmlns:r="http://schemas.openxmlformats.org/officeDocument/2006/relationships" id="272" r:id="R0337f65494b64384"/>
-    <p:sldId xmlns:r="http://schemas.openxmlformats.org/officeDocument/2006/relationships" id="273" r:id="R00ebceee19334062"/>
-    <p:sldId xmlns:r="http://schemas.openxmlformats.org/officeDocument/2006/relationships" id="274" r:id="Rc0a25f2f01bf4353"/>
-    <p:sldId xmlns:r="http://schemas.openxmlformats.org/officeDocument/2006/relationships" id="275" r:id="R77cbbfde4a0c4f49"/>
-    <p:sldId xmlns:r="http://schemas.openxmlformats.org/officeDocument/2006/relationships" id="276" r:id="R69a74c531af04205"/>
-    <p:sldId xmlns:r="http://schemas.openxmlformats.org/officeDocument/2006/relationships" id="277" r:id="R337adbfcc59a4d27"/>
-    <p:sldId xmlns:r="http://schemas.openxmlformats.org/officeDocument/2006/relationships" id="278" r:id="Rf0018eda18ca4202"/>
+    <p:sldId xmlns:r="http://schemas.openxmlformats.org/officeDocument/2006/relationships" id="256" r:id="R139041aa4c274fd1"/>
+    <p:sldId xmlns:r="http://schemas.openxmlformats.org/officeDocument/2006/relationships" id="257" r:id="R0231f7aeab7d435f"/>
+    <p:sldId xmlns:r="http://schemas.openxmlformats.org/officeDocument/2006/relationships" id="258" r:id="R5fe797f499fc4947"/>
+    <p:sldId xmlns:r="http://schemas.openxmlformats.org/officeDocument/2006/relationships" id="259" r:id="R5725de96cae14f2d"/>
+    <p:sldId xmlns:r="http://schemas.openxmlformats.org/officeDocument/2006/relationships" id="260" r:id="Rc12a71a7d5004cfc"/>
+    <p:sldId xmlns:r="http://schemas.openxmlformats.org/officeDocument/2006/relationships" id="261" r:id="Rc0d88c066a1d464c"/>
+    <p:sldId xmlns:r="http://schemas.openxmlformats.org/officeDocument/2006/relationships" id="262" r:id="Ra48fa687baa14566"/>
+    <p:sldId xmlns:r="http://schemas.openxmlformats.org/officeDocument/2006/relationships" id="263" r:id="Rfb9a269eec67440c"/>
+    <p:sldId xmlns:r="http://schemas.openxmlformats.org/officeDocument/2006/relationships" id="264" r:id="R8b2fcbb000354a21"/>
+    <p:sldId xmlns:r="http://schemas.openxmlformats.org/officeDocument/2006/relationships" id="265" r:id="R08812bb1c8bf4a69"/>
+    <p:sldId xmlns:r="http://schemas.openxmlformats.org/officeDocument/2006/relationships" id="266" r:id="R38b86a15d13a4794"/>
+    <p:sldId xmlns:r="http://schemas.openxmlformats.org/officeDocument/2006/relationships" id="267" r:id="R58d58960b92648a1"/>
+    <p:sldId xmlns:r="http://schemas.openxmlformats.org/officeDocument/2006/relationships" id="268" r:id="Rbfd9b425358041e1"/>
+    <p:sldId xmlns:r="http://schemas.openxmlformats.org/officeDocument/2006/relationships" id="269" r:id="R2b4f60c051d14f88"/>
+    <p:sldId xmlns:r="http://schemas.openxmlformats.org/officeDocument/2006/relationships" id="270" r:id="R62545c73fdd8473d"/>
+    <p:sldId xmlns:r="http://schemas.openxmlformats.org/officeDocument/2006/relationships" id="271" r:id="Rd66e722e0d4d4d54"/>
+    <p:sldId xmlns:r="http://schemas.openxmlformats.org/officeDocument/2006/relationships" id="272" r:id="R6c973c9b36e74eef"/>
+    <p:sldId xmlns:r="http://schemas.openxmlformats.org/officeDocument/2006/relationships" id="273" r:id="R8eb00d4c14104ffb"/>
+    <p:sldId xmlns:r="http://schemas.openxmlformats.org/officeDocument/2006/relationships" id="274" r:id="R89612a773a214dd9"/>
+    <p:sldId xmlns:r="http://schemas.openxmlformats.org/officeDocument/2006/relationships" id="275" r:id="R4952ced105d8416f"/>
+    <p:sldId xmlns:r="http://schemas.openxmlformats.org/officeDocument/2006/relationships" id="276" r:id="R50a42dae432f4fca"/>
+    <p:sldId xmlns:r="http://schemas.openxmlformats.org/officeDocument/2006/relationships" id="277" r:id="Rf162d1b22d194f58"/>
+    <p:sldId xmlns:r="http://schemas.openxmlformats.org/officeDocument/2006/relationships" id="278" r:id="R2c48914bc1cf44cf"/>
   </p:sldIdLst>
   <p:sldSz cx="12192000" cy="6858000"/>
   <p:notesSz cx="6858000" cy="9144000"/>
@@ -721,11 +721,14 @@
             </a:r>
           </a:p>
           <a:p xmlns:a="http://schemas.openxmlformats.org/drawingml/2006/main">
+            <a:r>
+              <a:t/>
+            </a:r>
             <a:endParaRPr/>
           </a:p>
           <a:p xmlns:a="http://schemas.openxmlformats.org/drawingml/2006/main">
             <a:r>
-              <a:t>The fourth verb extends reliability into professional understanding: make the domain map, ownership, and correct paths explicit instead of burying them in one large prompt.</a:t>
+              <a:t>Sandboxing, gates, and traceability form the reliability core. Knowledge Map is a separate layer of professional context that helps the model locate ownership and correct paths inside that boundary.</a:t>
             </a:r>
           </a:p>
         </p:txBody>
@@ -5133,16 +5136,16 @@
   </p:cSld>
   <p:clrMap bg1="lt1" tx1="dk1" bg2="lt2" tx2="dk2" accent1="accent1" accent2="accent2" accent3="accent3" accent4="accent4" accent5="accent5" accent6="accent6" hlink="hlink" folHlink="folHlink"/>
   <p:sldLayoutIdLst>
-    <p:sldLayoutId xmlns:r="http://schemas.openxmlformats.org/officeDocument/2006/relationships" id="2147483649" r:id="R8610ba6354dd4e25"/>
-    <p:sldLayoutId xmlns:r="http://schemas.openxmlformats.org/officeDocument/2006/relationships" id="2147483650" r:id="R888ef64a459c4343"/>
-    <p:sldLayoutId xmlns:r="http://schemas.openxmlformats.org/officeDocument/2006/relationships" id="2147483651" r:id="R62fe89989d484273"/>
-    <p:sldLayoutId xmlns:r="http://schemas.openxmlformats.org/officeDocument/2006/relationships" id="2147483652" r:id="Raf03a88dc8594fbc"/>
-    <p:sldLayoutId xmlns:r="http://schemas.openxmlformats.org/officeDocument/2006/relationships" id="2147483653" r:id="R83ce011d751f40a8"/>
-    <p:sldLayoutId xmlns:r="http://schemas.openxmlformats.org/officeDocument/2006/relationships" id="2147483654" r:id="Rce5f1cecf9094b2e"/>
-    <p:sldLayoutId xmlns:r="http://schemas.openxmlformats.org/officeDocument/2006/relationships" id="2147483655" r:id="R5681196296fa443b"/>
-    <p:sldLayoutId xmlns:r="http://schemas.openxmlformats.org/officeDocument/2006/relationships" id="2147483656" r:id="R3d526c6d4a724569"/>
-    <p:sldLayoutId xmlns:r="http://schemas.openxmlformats.org/officeDocument/2006/relationships" id="2147483657" r:id="Rd01cfe2c55234b62"/>
-    <p:sldLayoutId xmlns:r="http://schemas.openxmlformats.org/officeDocument/2006/relationships" id="2147483658" r:id="Raa75bb0f2ac84477"/>
+    <p:sldLayoutId xmlns:r="http://schemas.openxmlformats.org/officeDocument/2006/relationships" id="2147483649" r:id="Rece524855a3f4758"/>
+    <p:sldLayoutId xmlns:r="http://schemas.openxmlformats.org/officeDocument/2006/relationships" id="2147483650" r:id="Rb3d42a09673746c8"/>
+    <p:sldLayoutId xmlns:r="http://schemas.openxmlformats.org/officeDocument/2006/relationships" id="2147483651" r:id="R28aa7c8739e146f2"/>
+    <p:sldLayoutId xmlns:r="http://schemas.openxmlformats.org/officeDocument/2006/relationships" id="2147483652" r:id="R729fd029fc004686"/>
+    <p:sldLayoutId xmlns:r="http://schemas.openxmlformats.org/officeDocument/2006/relationships" id="2147483653" r:id="R520692b8230c429b"/>
+    <p:sldLayoutId xmlns:r="http://schemas.openxmlformats.org/officeDocument/2006/relationships" id="2147483654" r:id="R30eaf4b70b814d24"/>
+    <p:sldLayoutId xmlns:r="http://schemas.openxmlformats.org/officeDocument/2006/relationships" id="2147483655" r:id="Rc2501c2af7444d9a"/>
+    <p:sldLayoutId xmlns:r="http://schemas.openxmlformats.org/officeDocument/2006/relationships" id="2147483656" r:id="R8f04cc8048814b12"/>
+    <p:sldLayoutId xmlns:r="http://schemas.openxmlformats.org/officeDocument/2006/relationships" id="2147483657" r:id="R106e6d21d2424cc7"/>
+    <p:sldLayoutId xmlns:r="http://schemas.openxmlformats.org/officeDocument/2006/relationships" id="2147483658" r:id="R5b6b5159563b4f7f"/>
   </p:sldLayoutIdLst>
   <p:txStyles>
     <p:titleStyle>
@@ -5693,7 +5696,7 @@
           <p:nvPr/>
         </p:nvPicPr>
         <p:blipFill>
-          <a:blip xmlns:r="http://schemas.openxmlformats.org/officeDocument/2006/relationships" xmlns:a="http://schemas.openxmlformats.org/drawingml/2006/main" r:embed="Rdea03419d8db4f00"/>
+          <a:blip xmlns:r="http://schemas.openxmlformats.org/officeDocument/2006/relationships" xmlns:a="http://schemas.openxmlformats.org/drawingml/2006/main" r:embed="Rc8a57fa5407b4bc3"/>
           <a:stretch xmlns:a="http://schemas.openxmlformats.org/drawingml/2006/main">
             <a:fillRect l="0" t="0" r="0" b="0"/>
           </a:stretch>
@@ -5843,7 +5846,7 @@
           <p:nvPr/>
         </p:nvPicPr>
         <p:blipFill>
-          <a:blip xmlns:r="http://schemas.openxmlformats.org/officeDocument/2006/relationships" xmlns:a="http://schemas.openxmlformats.org/drawingml/2006/main" r:embed="R7c69b19f7185488a"/>
+          <a:blip xmlns:r="http://schemas.openxmlformats.org/officeDocument/2006/relationships" xmlns:a="http://schemas.openxmlformats.org/drawingml/2006/main" r:embed="R54ab48d8a73a4139"/>
           <a:stretch xmlns:a="http://schemas.openxmlformats.org/drawingml/2006/main">
             <a:fillRect l="0" t="0" r="0" b="0"/>
           </a:stretch>
@@ -5867,7 +5870,7 @@
           <p:nvPr/>
         </p:nvPicPr>
         <p:blipFill>
-          <a:blip xmlns:r="http://schemas.openxmlformats.org/officeDocument/2006/relationships" xmlns:a="http://schemas.openxmlformats.org/drawingml/2006/main" r:embed="Rc044db1645544576"/>
+          <a:blip xmlns:r="http://schemas.openxmlformats.org/officeDocument/2006/relationships" xmlns:a="http://schemas.openxmlformats.org/drawingml/2006/main" r:embed="R3a35dd5593aa4ba9"/>
           <a:stretch xmlns:a="http://schemas.openxmlformats.org/drawingml/2006/main">
             <a:fillRect l="0" t="0" r="0" b="0"/>
           </a:stretch>
@@ -5891,7 +5894,7 @@
           <p:nvPr/>
         </p:nvPicPr>
         <p:blipFill>
-          <a:blip xmlns:r="http://schemas.openxmlformats.org/officeDocument/2006/relationships" xmlns:a="http://schemas.openxmlformats.org/drawingml/2006/main" r:embed="R012739ed439243cb"/>
+          <a:blip xmlns:r="http://schemas.openxmlformats.org/officeDocument/2006/relationships" xmlns:a="http://schemas.openxmlformats.org/drawingml/2006/main" r:embed="R036c1a37f3ce4d34"/>
           <a:stretch xmlns:a="http://schemas.openxmlformats.org/drawingml/2006/main">
             <a:fillRect l="0" t="0" r="0" b="0"/>
           </a:stretch>
@@ -5915,7 +5918,7 @@
           <p:nvPr/>
         </p:nvPicPr>
         <p:blipFill>
-          <a:blip xmlns:r="http://schemas.openxmlformats.org/officeDocument/2006/relationships" xmlns:a="http://schemas.openxmlformats.org/drawingml/2006/main" r:embed="R12b4b51c68c14b4a"/>
+          <a:blip xmlns:r="http://schemas.openxmlformats.org/officeDocument/2006/relationships" xmlns:a="http://schemas.openxmlformats.org/drawingml/2006/main" r:embed="R42e6d16df48b4007"/>
           <a:stretch xmlns:a="http://schemas.openxmlformats.org/drawingml/2006/main">
             <a:fillRect l="0" t="0" r="0" b="0"/>
           </a:stretch>
@@ -5961,7 +5964,7 @@
           <p:nvPr/>
         </p:nvPicPr>
         <p:blipFill>
-          <a:blip xmlns:r="http://schemas.openxmlformats.org/officeDocument/2006/relationships" xmlns:a="http://schemas.openxmlformats.org/drawingml/2006/main" r:embed="R67a526e73b524329"/>
+          <a:blip xmlns:r="http://schemas.openxmlformats.org/officeDocument/2006/relationships" xmlns:a="http://schemas.openxmlformats.org/drawingml/2006/main" r:embed="R11c8f146e3f743e8"/>
           <a:stretch xmlns:a="http://schemas.openxmlformats.org/drawingml/2006/main">
             <a:fillRect l="0" t="0" r="0" b="0"/>
           </a:stretch>
@@ -5985,7 +5988,7 @@
           <p:nvPr/>
         </p:nvPicPr>
         <p:blipFill>
-          <a:blip xmlns:r="http://schemas.openxmlformats.org/officeDocument/2006/relationships" xmlns:a="http://schemas.openxmlformats.org/drawingml/2006/main" r:embed="Rac65740d5c8c43ad"/>
+          <a:blip xmlns:r="http://schemas.openxmlformats.org/officeDocument/2006/relationships" xmlns:a="http://schemas.openxmlformats.org/drawingml/2006/main" r:embed="R2ba4a7a60e4148e2"/>
           <a:stretch xmlns:a="http://schemas.openxmlformats.org/drawingml/2006/main">
             <a:fillRect l="0" t="0" r="0" b="0"/>
           </a:stretch>
@@ -6009,7 +6012,7 @@
           <p:nvPr/>
         </p:nvPicPr>
         <p:blipFill>
-          <a:blip xmlns:r="http://schemas.openxmlformats.org/officeDocument/2006/relationships" xmlns:a="http://schemas.openxmlformats.org/drawingml/2006/main" r:embed="Re38ff7d6184149c1"/>
+          <a:blip xmlns:r="http://schemas.openxmlformats.org/officeDocument/2006/relationships" xmlns:a="http://schemas.openxmlformats.org/drawingml/2006/main" r:embed="Ra8b4a5b3684d46aa"/>
           <a:stretch xmlns:a="http://schemas.openxmlformats.org/drawingml/2006/main">
             <a:fillRect l="0" t="0" r="0" b="0"/>
           </a:stretch>
@@ -6033,7 +6036,7 @@
           <p:nvPr/>
         </p:nvPicPr>
         <p:blipFill>
-          <a:blip xmlns:r="http://schemas.openxmlformats.org/officeDocument/2006/relationships" xmlns:a="http://schemas.openxmlformats.org/drawingml/2006/main" r:embed="R126f59691a494f43"/>
+          <a:blip xmlns:r="http://schemas.openxmlformats.org/officeDocument/2006/relationships" xmlns:a="http://schemas.openxmlformats.org/drawingml/2006/main" r:embed="R7984c0fda1e3455b"/>
           <a:stretch xmlns:a="http://schemas.openxmlformats.org/drawingml/2006/main">
             <a:fillRect l="0" t="0" r="0" b="0"/>
           </a:stretch>
@@ -6857,7 +6860,7 @@
           <p:nvPr/>
         </p:nvPicPr>
         <p:blipFill>
-          <a:blip xmlns:r="http://schemas.openxmlformats.org/officeDocument/2006/relationships" xmlns:a="http://schemas.openxmlformats.org/drawingml/2006/main" r:embed="R537010654cf04cf2"/>
+          <a:blip xmlns:r="http://schemas.openxmlformats.org/officeDocument/2006/relationships" xmlns:a="http://schemas.openxmlformats.org/drawingml/2006/main" r:embed="Rbd6e3054847f4a21"/>
           <a:stretch xmlns:a="http://schemas.openxmlformats.org/drawingml/2006/main">
             <a:fillRect l="0" t="0" r="0" b="0"/>
           </a:stretch>
@@ -6881,7 +6884,7 @@
           <p:nvPr/>
         </p:nvPicPr>
         <p:blipFill>
-          <a:blip xmlns:r="http://schemas.openxmlformats.org/officeDocument/2006/relationships" xmlns:a="http://schemas.openxmlformats.org/drawingml/2006/main" r:embed="Ref3baa28ea274ad7"/>
+          <a:blip xmlns:r="http://schemas.openxmlformats.org/officeDocument/2006/relationships" xmlns:a="http://schemas.openxmlformats.org/drawingml/2006/main" r:embed="R96cbada7dc4b44e0"/>
           <a:stretch xmlns:a="http://schemas.openxmlformats.org/drawingml/2006/main">
             <a:fillRect l="0" t="0" r="0" b="0"/>
           </a:stretch>
@@ -6905,7 +6908,7 @@
           <p:nvPr/>
         </p:nvPicPr>
         <p:blipFill>
-          <a:blip xmlns:r="http://schemas.openxmlformats.org/officeDocument/2006/relationships" xmlns:a="http://schemas.openxmlformats.org/drawingml/2006/main" r:embed="Rac2fc01ccb464ecf"/>
+          <a:blip xmlns:r="http://schemas.openxmlformats.org/officeDocument/2006/relationships" xmlns:a="http://schemas.openxmlformats.org/drawingml/2006/main" r:embed="R71cba4c9ffca4969"/>
           <a:stretch xmlns:a="http://schemas.openxmlformats.org/drawingml/2006/main">
             <a:fillRect l="0" t="0" r="0" b="0"/>
           </a:stretch>
@@ -6929,7 +6932,7 @@
           <p:nvPr/>
         </p:nvPicPr>
         <p:blipFill>
-          <a:blip xmlns:r="http://schemas.openxmlformats.org/officeDocument/2006/relationships" xmlns:a="http://schemas.openxmlformats.org/drawingml/2006/main" r:embed="R43eb16241bf74e1d"/>
+          <a:blip xmlns:r="http://schemas.openxmlformats.org/officeDocument/2006/relationships" xmlns:a="http://schemas.openxmlformats.org/drawingml/2006/main" r:embed="Rdbdd31991981401d"/>
           <a:stretch xmlns:a="http://schemas.openxmlformats.org/drawingml/2006/main">
             <a:fillRect l="0" t="0" r="0" b="0"/>
           </a:stretch>
@@ -7483,7 +7486,7 @@
           <p:nvPr/>
         </p:nvPicPr>
         <p:blipFill>
-          <a:blip xmlns:r="http://schemas.openxmlformats.org/officeDocument/2006/relationships" xmlns:a="http://schemas.openxmlformats.org/drawingml/2006/main" r:embed="R0f216d774aa54304"/>
+          <a:blip xmlns:r="http://schemas.openxmlformats.org/officeDocument/2006/relationships" xmlns:a="http://schemas.openxmlformats.org/drawingml/2006/main" r:embed="R41aa1790844244cf"/>
           <a:stretch xmlns:a="http://schemas.openxmlformats.org/drawingml/2006/main">
             <a:fillRect l="0" t="0" r="0" b="0"/>
           </a:stretch>
@@ -7507,7 +7510,7 @@
           <p:nvPr/>
         </p:nvPicPr>
         <p:blipFill>
-          <a:blip xmlns:r="http://schemas.openxmlformats.org/officeDocument/2006/relationships" xmlns:a="http://schemas.openxmlformats.org/drawingml/2006/main" r:embed="Rc34dbd2ab7ae4808"/>
+          <a:blip xmlns:r="http://schemas.openxmlformats.org/officeDocument/2006/relationships" xmlns:a="http://schemas.openxmlformats.org/drawingml/2006/main" r:embed="Ra934bc82c4a24308"/>
           <a:stretch xmlns:a="http://schemas.openxmlformats.org/drawingml/2006/main">
             <a:fillRect l="0" t="0" r="0" b="0"/>
           </a:stretch>
@@ -7531,7 +7534,7 @@
           <p:nvPr/>
         </p:nvPicPr>
         <p:blipFill>
-          <a:blip xmlns:r="http://schemas.openxmlformats.org/officeDocument/2006/relationships" xmlns:a="http://schemas.openxmlformats.org/drawingml/2006/main" r:embed="Rcfe8a219979e49dc"/>
+          <a:blip xmlns:r="http://schemas.openxmlformats.org/officeDocument/2006/relationships" xmlns:a="http://schemas.openxmlformats.org/drawingml/2006/main" r:embed="Rff8a65cb8a4d4344"/>
           <a:stretch xmlns:a="http://schemas.openxmlformats.org/drawingml/2006/main">
             <a:fillRect l="0" t="0" r="0" b="0"/>
           </a:stretch>
@@ -7555,7 +7558,7 @@
           <p:nvPr/>
         </p:nvPicPr>
         <p:blipFill>
-          <a:blip xmlns:r="http://schemas.openxmlformats.org/officeDocument/2006/relationships" xmlns:a="http://schemas.openxmlformats.org/drawingml/2006/main" r:embed="R6aa22493d26f4e7b"/>
+          <a:blip xmlns:r="http://schemas.openxmlformats.org/officeDocument/2006/relationships" xmlns:a="http://schemas.openxmlformats.org/drawingml/2006/main" r:embed="R736e8989034b4034"/>
           <a:stretch xmlns:a="http://schemas.openxmlformats.org/drawingml/2006/main">
             <a:fillRect l="0" t="0" r="0" b="0"/>
           </a:stretch>
@@ -8176,7 +8179,7 @@
           <p:nvPr/>
         </p:nvPicPr>
         <p:blipFill>
-          <a:blip xmlns:r="http://schemas.openxmlformats.org/officeDocument/2006/relationships" xmlns:a="http://schemas.openxmlformats.org/drawingml/2006/main" r:embed="R14aae598581047ea"/>
+          <a:blip xmlns:r="http://schemas.openxmlformats.org/officeDocument/2006/relationships" xmlns:a="http://schemas.openxmlformats.org/drawingml/2006/main" r:embed="Rc5b27820b4344367"/>
           <a:stretch xmlns:a="http://schemas.openxmlformats.org/drawingml/2006/main">
             <a:fillRect l="0" t="0" r="0" b="0"/>
           </a:stretch>
@@ -8200,7 +8203,7 @@
           <p:nvPr/>
         </p:nvPicPr>
         <p:blipFill>
-          <a:blip xmlns:r="http://schemas.openxmlformats.org/officeDocument/2006/relationships" xmlns:a="http://schemas.openxmlformats.org/drawingml/2006/main" r:embed="R04031a4f48914dc4"/>
+          <a:blip xmlns:r="http://schemas.openxmlformats.org/officeDocument/2006/relationships" xmlns:a="http://schemas.openxmlformats.org/drawingml/2006/main" r:embed="R8a51e38cac894fc6"/>
           <a:stretch xmlns:a="http://schemas.openxmlformats.org/drawingml/2006/main">
             <a:fillRect l="0" t="0" r="0" b="0"/>
           </a:stretch>
@@ -8224,7 +8227,7 @@
           <p:nvPr/>
         </p:nvPicPr>
         <p:blipFill>
-          <a:blip xmlns:r="http://schemas.openxmlformats.org/officeDocument/2006/relationships" xmlns:a="http://schemas.openxmlformats.org/drawingml/2006/main" r:embed="R2b7b73881f134b61"/>
+          <a:blip xmlns:r="http://schemas.openxmlformats.org/officeDocument/2006/relationships" xmlns:a="http://schemas.openxmlformats.org/drawingml/2006/main" r:embed="Rd6dd4919aad04d66"/>
           <a:stretch xmlns:a="http://schemas.openxmlformats.org/drawingml/2006/main">
             <a:fillRect l="0" t="0" r="0" b="0"/>
           </a:stretch>
@@ -8248,7 +8251,7 @@
           <p:nvPr/>
         </p:nvPicPr>
         <p:blipFill>
-          <a:blip xmlns:r="http://schemas.openxmlformats.org/officeDocument/2006/relationships" xmlns:a="http://schemas.openxmlformats.org/drawingml/2006/main" r:embed="R5c3b902165a04b80"/>
+          <a:blip xmlns:r="http://schemas.openxmlformats.org/officeDocument/2006/relationships" xmlns:a="http://schemas.openxmlformats.org/drawingml/2006/main" r:embed="Rb5f5c71a600c4ed3"/>
           <a:stretch xmlns:a="http://schemas.openxmlformats.org/drawingml/2006/main">
             <a:fillRect l="0" t="0" r="0" b="0"/>
           </a:stretch>
@@ -8938,7 +8941,7 @@
           <p:nvPr/>
         </p:nvPicPr>
         <p:blipFill>
-          <a:blip xmlns:r="http://schemas.openxmlformats.org/officeDocument/2006/relationships" xmlns:a="http://schemas.openxmlformats.org/drawingml/2006/main" r:embed="R4e7d681a43564095"/>
+          <a:blip xmlns:r="http://schemas.openxmlformats.org/officeDocument/2006/relationships" xmlns:a="http://schemas.openxmlformats.org/drawingml/2006/main" r:embed="Ra5ea9131fafb4fed"/>
           <a:stretch xmlns:a="http://schemas.openxmlformats.org/drawingml/2006/main">
             <a:fillRect l="0" t="0" r="0" b="0"/>
           </a:stretch>
@@ -8962,7 +8965,7 @@
           <p:nvPr/>
         </p:nvPicPr>
         <p:blipFill>
-          <a:blip xmlns:r="http://schemas.openxmlformats.org/officeDocument/2006/relationships" xmlns:a="http://schemas.openxmlformats.org/drawingml/2006/main" r:embed="R6a30d5680d5f43c7"/>
+          <a:blip xmlns:r="http://schemas.openxmlformats.org/officeDocument/2006/relationships" xmlns:a="http://schemas.openxmlformats.org/drawingml/2006/main" r:embed="R9f632a32e27c4803"/>
           <a:stretch xmlns:a="http://schemas.openxmlformats.org/drawingml/2006/main">
             <a:fillRect l="0" t="0" r="0" b="0"/>
           </a:stretch>
@@ -8986,7 +8989,7 @@
           <p:nvPr/>
         </p:nvPicPr>
         <p:blipFill>
-          <a:blip xmlns:r="http://schemas.openxmlformats.org/officeDocument/2006/relationships" xmlns:a="http://schemas.openxmlformats.org/drawingml/2006/main" r:embed="R786fa21ae9a84f4f"/>
+          <a:blip xmlns:r="http://schemas.openxmlformats.org/officeDocument/2006/relationships" xmlns:a="http://schemas.openxmlformats.org/drawingml/2006/main" r:embed="R28b87eb4cf3b4f06"/>
           <a:stretch xmlns:a="http://schemas.openxmlformats.org/drawingml/2006/main">
             <a:fillRect l="0" t="0" r="0" b="0"/>
           </a:stretch>
@@ -9010,7 +9013,7 @@
           <p:nvPr/>
         </p:nvPicPr>
         <p:blipFill>
-          <a:blip xmlns:r="http://schemas.openxmlformats.org/officeDocument/2006/relationships" xmlns:a="http://schemas.openxmlformats.org/drawingml/2006/main" r:embed="R5bc9877664dc4c23"/>
+          <a:blip xmlns:r="http://schemas.openxmlformats.org/officeDocument/2006/relationships" xmlns:a="http://schemas.openxmlformats.org/drawingml/2006/main" r:embed="R54c6d9a99ea24461"/>
           <a:stretch xmlns:a="http://schemas.openxmlformats.org/drawingml/2006/main">
             <a:fillRect l="0" t="0" r="0" b="0"/>
           </a:stretch>
@@ -10008,7 +10011,7 @@
           <p:nvPr/>
         </p:nvPicPr>
         <p:blipFill>
-          <a:blip xmlns:r="http://schemas.openxmlformats.org/officeDocument/2006/relationships" xmlns:a="http://schemas.openxmlformats.org/drawingml/2006/main" r:embed="Rc64d15cf68654104"/>
+          <a:blip xmlns:r="http://schemas.openxmlformats.org/officeDocument/2006/relationships" xmlns:a="http://schemas.openxmlformats.org/drawingml/2006/main" r:embed="R37a2689536684e53"/>
           <a:stretch xmlns:a="http://schemas.openxmlformats.org/drawingml/2006/main">
             <a:fillRect l="0" t="0" r="0" b="0"/>
           </a:stretch>
@@ -10032,7 +10035,7 @@
           <p:nvPr/>
         </p:nvPicPr>
         <p:blipFill>
-          <a:blip xmlns:r="http://schemas.openxmlformats.org/officeDocument/2006/relationships" xmlns:a="http://schemas.openxmlformats.org/drawingml/2006/main" r:embed="R53d85ce06bb0410d"/>
+          <a:blip xmlns:r="http://schemas.openxmlformats.org/officeDocument/2006/relationships" xmlns:a="http://schemas.openxmlformats.org/drawingml/2006/main" r:embed="R279c43ab19984f9b"/>
           <a:stretch xmlns:a="http://schemas.openxmlformats.org/drawingml/2006/main">
             <a:fillRect l="0" t="0" r="0" b="0"/>
           </a:stretch>
@@ -10056,7 +10059,7 @@
           <p:nvPr/>
         </p:nvPicPr>
         <p:blipFill>
-          <a:blip xmlns:r="http://schemas.openxmlformats.org/officeDocument/2006/relationships" xmlns:a="http://schemas.openxmlformats.org/drawingml/2006/main" r:embed="R644d9fdb75014806"/>
+          <a:blip xmlns:r="http://schemas.openxmlformats.org/officeDocument/2006/relationships" xmlns:a="http://schemas.openxmlformats.org/drawingml/2006/main" r:embed="Rd7cc05bc7e87440d"/>
           <a:stretch xmlns:a="http://schemas.openxmlformats.org/drawingml/2006/main">
             <a:fillRect l="0" t="0" r="0" b="0"/>
           </a:stretch>
@@ -10080,7 +10083,7 @@
           <p:nvPr/>
         </p:nvPicPr>
         <p:blipFill>
-          <a:blip xmlns:r="http://schemas.openxmlformats.org/officeDocument/2006/relationships" xmlns:a="http://schemas.openxmlformats.org/drawingml/2006/main" r:embed="R1ae6aec1e1584f0f"/>
+          <a:blip xmlns:r="http://schemas.openxmlformats.org/officeDocument/2006/relationships" xmlns:a="http://schemas.openxmlformats.org/drawingml/2006/main" r:embed="R6b02831e41aa4935"/>
           <a:stretch xmlns:a="http://schemas.openxmlformats.org/drawingml/2006/main">
             <a:fillRect l="0" t="0" r="0" b="0"/>
           </a:stretch>
@@ -10690,7 +10693,7 @@
           <p:nvPr/>
         </p:nvPicPr>
         <p:blipFill>
-          <a:blip xmlns:r="http://schemas.openxmlformats.org/officeDocument/2006/relationships" xmlns:a="http://schemas.openxmlformats.org/drawingml/2006/main" r:embed="R5c00600025f74c9e"/>
+          <a:blip xmlns:r="http://schemas.openxmlformats.org/officeDocument/2006/relationships" xmlns:a="http://schemas.openxmlformats.org/drawingml/2006/main" r:embed="Rf320a9fedd3241b2"/>
           <a:stretch xmlns:a="http://schemas.openxmlformats.org/drawingml/2006/main">
             <a:fillRect l="0" t="0" r="0" b="0"/>
           </a:stretch>
@@ -10714,7 +10717,7 @@
           <p:nvPr/>
         </p:nvPicPr>
         <p:blipFill>
-          <a:blip xmlns:r="http://schemas.openxmlformats.org/officeDocument/2006/relationships" xmlns:a="http://schemas.openxmlformats.org/drawingml/2006/main" r:embed="R2b27a5a584234ac2"/>
+          <a:blip xmlns:r="http://schemas.openxmlformats.org/officeDocument/2006/relationships" xmlns:a="http://schemas.openxmlformats.org/drawingml/2006/main" r:embed="Rbfd11e14e1264ff8"/>
           <a:stretch xmlns:a="http://schemas.openxmlformats.org/drawingml/2006/main">
             <a:fillRect l="0" t="0" r="0" b="0"/>
           </a:stretch>
@@ -10738,7 +10741,7 @@
           <p:nvPr/>
         </p:nvPicPr>
         <p:blipFill>
-          <a:blip xmlns:r="http://schemas.openxmlformats.org/officeDocument/2006/relationships" xmlns:a="http://schemas.openxmlformats.org/drawingml/2006/main" r:embed="Rd2371c2abeb741ac"/>
+          <a:blip xmlns:r="http://schemas.openxmlformats.org/officeDocument/2006/relationships" xmlns:a="http://schemas.openxmlformats.org/drawingml/2006/main" r:embed="R002eaa82c6f74aaf"/>
           <a:stretch xmlns:a="http://schemas.openxmlformats.org/drawingml/2006/main">
             <a:fillRect l="0" t="0" r="0" b="0"/>
           </a:stretch>
@@ -10762,7 +10765,7 @@
           <p:nvPr/>
         </p:nvPicPr>
         <p:blipFill>
-          <a:blip xmlns:r="http://schemas.openxmlformats.org/officeDocument/2006/relationships" xmlns:a="http://schemas.openxmlformats.org/drawingml/2006/main" r:embed="R9b75b39a2e7a4e49"/>
+          <a:blip xmlns:r="http://schemas.openxmlformats.org/officeDocument/2006/relationships" xmlns:a="http://schemas.openxmlformats.org/drawingml/2006/main" r:embed="R4182327fd2464553"/>
           <a:stretch xmlns:a="http://schemas.openxmlformats.org/drawingml/2006/main">
             <a:fillRect l="0" t="0" r="0" b="0"/>
           </a:stretch>
@@ -11383,7 +11386,7 @@
           <p:nvPr/>
         </p:nvPicPr>
         <p:blipFill>
-          <a:blip xmlns:r="http://schemas.openxmlformats.org/officeDocument/2006/relationships" xmlns:a="http://schemas.openxmlformats.org/drawingml/2006/main" r:embed="Reda5ab9454a04435"/>
+          <a:blip xmlns:r="http://schemas.openxmlformats.org/officeDocument/2006/relationships" xmlns:a="http://schemas.openxmlformats.org/drawingml/2006/main" r:embed="R09d028be30b14dc1"/>
           <a:stretch xmlns:a="http://schemas.openxmlformats.org/drawingml/2006/main">
             <a:fillRect l="0" t="0" r="0" b="0"/>
           </a:stretch>
@@ -11407,7 +11410,7 @@
           <p:nvPr/>
         </p:nvPicPr>
         <p:blipFill>
-          <a:blip xmlns:r="http://schemas.openxmlformats.org/officeDocument/2006/relationships" xmlns:a="http://schemas.openxmlformats.org/drawingml/2006/main" r:embed="Rb8e9de8ae66a487c"/>
+          <a:blip xmlns:r="http://schemas.openxmlformats.org/officeDocument/2006/relationships" xmlns:a="http://schemas.openxmlformats.org/drawingml/2006/main" r:embed="R478af05abdd140bb"/>
           <a:stretch xmlns:a="http://schemas.openxmlformats.org/drawingml/2006/main">
             <a:fillRect l="0" t="0" r="0" b="0"/>
           </a:stretch>
@@ -11431,7 +11434,7 @@
           <p:nvPr/>
         </p:nvPicPr>
         <p:blipFill>
-          <a:blip xmlns:r="http://schemas.openxmlformats.org/officeDocument/2006/relationships" xmlns:a="http://schemas.openxmlformats.org/drawingml/2006/main" r:embed="R447939ff202b4ddf"/>
+          <a:blip xmlns:r="http://schemas.openxmlformats.org/officeDocument/2006/relationships" xmlns:a="http://schemas.openxmlformats.org/drawingml/2006/main" r:embed="R59af4692dafa40f5"/>
           <a:stretch xmlns:a="http://schemas.openxmlformats.org/drawingml/2006/main">
             <a:fillRect l="0" t="0" r="0" b="0"/>
           </a:stretch>
@@ -11455,7 +11458,7 @@
           <p:nvPr/>
         </p:nvPicPr>
         <p:blipFill>
-          <a:blip xmlns:r="http://schemas.openxmlformats.org/officeDocument/2006/relationships" xmlns:a="http://schemas.openxmlformats.org/drawingml/2006/main" r:embed="R3c071860524245c2"/>
+          <a:blip xmlns:r="http://schemas.openxmlformats.org/officeDocument/2006/relationships" xmlns:a="http://schemas.openxmlformats.org/drawingml/2006/main" r:embed="R904938b1c6ed4283"/>
           <a:stretch xmlns:a="http://schemas.openxmlformats.org/drawingml/2006/main">
             <a:fillRect l="0" t="0" r="0" b="0"/>
           </a:stretch>
@@ -12625,7 +12628,7 @@
           <p:nvPr/>
         </p:nvPicPr>
         <p:blipFill>
-          <a:blip xmlns:r="http://schemas.openxmlformats.org/officeDocument/2006/relationships" xmlns:a="http://schemas.openxmlformats.org/drawingml/2006/main" r:embed="Re14bf32e0cab430f"/>
+          <a:blip xmlns:r="http://schemas.openxmlformats.org/officeDocument/2006/relationships" xmlns:a="http://schemas.openxmlformats.org/drawingml/2006/main" r:embed="R34640d1da664463a"/>
           <a:stretch xmlns:a="http://schemas.openxmlformats.org/drawingml/2006/main">
             <a:fillRect l="0" t="0" r="0" b="0"/>
           </a:stretch>
@@ -12649,7 +12652,7 @@
           <p:nvPr/>
         </p:nvPicPr>
         <p:blipFill>
-          <a:blip xmlns:r="http://schemas.openxmlformats.org/officeDocument/2006/relationships" xmlns:a="http://schemas.openxmlformats.org/drawingml/2006/main" r:embed="R2e46a67dcbc94d9d"/>
+          <a:blip xmlns:r="http://schemas.openxmlformats.org/officeDocument/2006/relationships" xmlns:a="http://schemas.openxmlformats.org/drawingml/2006/main" r:embed="R3a4e749147f142ff"/>
           <a:stretch xmlns:a="http://schemas.openxmlformats.org/drawingml/2006/main">
             <a:fillRect l="0" t="0" r="0" b="0"/>
           </a:stretch>
@@ -12673,7 +12676,7 @@
           <p:nvPr/>
         </p:nvPicPr>
         <p:blipFill>
-          <a:blip xmlns:r="http://schemas.openxmlformats.org/officeDocument/2006/relationships" xmlns:a="http://schemas.openxmlformats.org/drawingml/2006/main" r:embed="R39ee5478903d47bd"/>
+          <a:blip xmlns:r="http://schemas.openxmlformats.org/officeDocument/2006/relationships" xmlns:a="http://schemas.openxmlformats.org/drawingml/2006/main" r:embed="R041bb41a51804437"/>
           <a:stretch xmlns:a="http://schemas.openxmlformats.org/drawingml/2006/main">
             <a:fillRect l="0" t="0" r="0" b="0"/>
           </a:stretch>
@@ -12697,7 +12700,7 @@
           <p:nvPr/>
         </p:nvPicPr>
         <p:blipFill>
-          <a:blip xmlns:r="http://schemas.openxmlformats.org/officeDocument/2006/relationships" xmlns:a="http://schemas.openxmlformats.org/drawingml/2006/main" r:embed="Rd2bf5d40d03a42ba"/>
+          <a:blip xmlns:r="http://schemas.openxmlformats.org/officeDocument/2006/relationships" xmlns:a="http://schemas.openxmlformats.org/drawingml/2006/main" r:embed="R3c293885eb4442a5"/>
           <a:stretch xmlns:a="http://schemas.openxmlformats.org/drawingml/2006/main">
             <a:fillRect l="0" t="0" r="0" b="0"/>
           </a:stretch>
@@ -13875,7 +13878,7 @@
           <p:nvPr/>
         </p:nvPicPr>
         <p:blipFill>
-          <a:blip xmlns:r="http://schemas.openxmlformats.org/officeDocument/2006/relationships" xmlns:a="http://schemas.openxmlformats.org/drawingml/2006/main" r:embed="R8f33f20caa524a4b"/>
+          <a:blip xmlns:r="http://schemas.openxmlformats.org/officeDocument/2006/relationships" xmlns:a="http://schemas.openxmlformats.org/drawingml/2006/main" r:embed="R866b7d793310421c"/>
           <a:stretch xmlns:a="http://schemas.openxmlformats.org/drawingml/2006/main">
             <a:fillRect l="0" t="0" r="0" b="0"/>
           </a:stretch>
@@ -13899,7 +13902,7 @@
           <p:nvPr/>
         </p:nvPicPr>
         <p:blipFill>
-          <a:blip xmlns:r="http://schemas.openxmlformats.org/officeDocument/2006/relationships" xmlns:a="http://schemas.openxmlformats.org/drawingml/2006/main" r:embed="R8c3b11283a7a4d11"/>
+          <a:blip xmlns:r="http://schemas.openxmlformats.org/officeDocument/2006/relationships" xmlns:a="http://schemas.openxmlformats.org/drawingml/2006/main" r:embed="Rc8162fef86104c73"/>
           <a:stretch xmlns:a="http://schemas.openxmlformats.org/drawingml/2006/main">
             <a:fillRect l="0" t="0" r="0" b="0"/>
           </a:stretch>
@@ -13923,7 +13926,7 @@
           <p:nvPr/>
         </p:nvPicPr>
         <p:blipFill>
-          <a:blip xmlns:r="http://schemas.openxmlformats.org/officeDocument/2006/relationships" xmlns:a="http://schemas.openxmlformats.org/drawingml/2006/main" r:embed="R2b4da983cada485a"/>
+          <a:blip xmlns:r="http://schemas.openxmlformats.org/officeDocument/2006/relationships" xmlns:a="http://schemas.openxmlformats.org/drawingml/2006/main" r:embed="R9db8e6c5a6c04af6"/>
           <a:stretch xmlns:a="http://schemas.openxmlformats.org/drawingml/2006/main">
             <a:fillRect l="0" t="0" r="0" b="0"/>
           </a:stretch>
@@ -13947,7 +13950,7 @@
           <p:nvPr/>
         </p:nvPicPr>
         <p:blipFill>
-          <a:blip xmlns:r="http://schemas.openxmlformats.org/officeDocument/2006/relationships" xmlns:a="http://schemas.openxmlformats.org/drawingml/2006/main" r:embed="Ree0b51cadd7d485c"/>
+          <a:blip xmlns:r="http://schemas.openxmlformats.org/officeDocument/2006/relationships" xmlns:a="http://schemas.openxmlformats.org/drawingml/2006/main" r:embed="Rf5823026cb284853"/>
           <a:stretch xmlns:a="http://schemas.openxmlformats.org/drawingml/2006/main">
             <a:fillRect l="0" t="0" r="0" b="0"/>
           </a:stretch>
@@ -14904,7 +14907,7 @@
           <p:nvPr/>
         </p:nvPicPr>
         <p:blipFill>
-          <a:blip xmlns:r="http://schemas.openxmlformats.org/officeDocument/2006/relationships" xmlns:a="http://schemas.openxmlformats.org/drawingml/2006/main" r:embed="R2158e14398e64673"/>
+          <a:blip xmlns:r="http://schemas.openxmlformats.org/officeDocument/2006/relationships" xmlns:a="http://schemas.openxmlformats.org/drawingml/2006/main" r:embed="R516402954ca04c02"/>
           <a:stretch xmlns:a="http://schemas.openxmlformats.org/drawingml/2006/main">
             <a:fillRect l="0" t="0" r="0" b="0"/>
           </a:stretch>
@@ -14928,7 +14931,7 @@
           <p:nvPr/>
         </p:nvPicPr>
         <p:blipFill>
-          <a:blip xmlns:r="http://schemas.openxmlformats.org/officeDocument/2006/relationships" xmlns:a="http://schemas.openxmlformats.org/drawingml/2006/main" r:embed="R5b4c4defd4964319"/>
+          <a:blip xmlns:r="http://schemas.openxmlformats.org/officeDocument/2006/relationships" xmlns:a="http://schemas.openxmlformats.org/drawingml/2006/main" r:embed="R182589fab6b9409f"/>
           <a:stretch xmlns:a="http://schemas.openxmlformats.org/drawingml/2006/main">
             <a:fillRect l="0" t="0" r="0" b="0"/>
           </a:stretch>
@@ -14952,7 +14955,7 @@
           <p:nvPr/>
         </p:nvPicPr>
         <p:blipFill>
-          <a:blip xmlns:r="http://schemas.openxmlformats.org/officeDocument/2006/relationships" xmlns:a="http://schemas.openxmlformats.org/drawingml/2006/main" r:embed="Rfcf9abf0ac8443ad"/>
+          <a:blip xmlns:r="http://schemas.openxmlformats.org/officeDocument/2006/relationships" xmlns:a="http://schemas.openxmlformats.org/drawingml/2006/main" r:embed="Rda92e4a2c6b8420a"/>
           <a:stretch xmlns:a="http://schemas.openxmlformats.org/drawingml/2006/main">
             <a:fillRect l="0" t="0" r="0" b="0"/>
           </a:stretch>
@@ -14976,7 +14979,7 @@
           <p:nvPr/>
         </p:nvPicPr>
         <p:blipFill>
-          <a:blip xmlns:r="http://schemas.openxmlformats.org/officeDocument/2006/relationships" xmlns:a="http://schemas.openxmlformats.org/drawingml/2006/main" r:embed="Rbc7c7280153845da"/>
+          <a:blip xmlns:r="http://schemas.openxmlformats.org/officeDocument/2006/relationships" xmlns:a="http://schemas.openxmlformats.org/drawingml/2006/main" r:embed="Rba117e46744f4d7e"/>
           <a:stretch xmlns:a="http://schemas.openxmlformats.org/drawingml/2006/main">
             <a:fillRect l="0" t="0" r="0" b="0"/>
           </a:stretch>
@@ -16141,7 +16144,7 @@
           <p:nvPr/>
         </p:nvPicPr>
         <p:blipFill>
-          <a:blip xmlns:r="http://schemas.openxmlformats.org/officeDocument/2006/relationships" xmlns:a="http://schemas.openxmlformats.org/drawingml/2006/main" r:embed="Rd048bf37a13544a8"/>
+          <a:blip xmlns:r="http://schemas.openxmlformats.org/officeDocument/2006/relationships" xmlns:a="http://schemas.openxmlformats.org/drawingml/2006/main" r:embed="R7885cb5d94324f5f"/>
           <a:stretch xmlns:a="http://schemas.openxmlformats.org/drawingml/2006/main">
             <a:fillRect l="0" t="0" r="0" b="0"/>
           </a:stretch>
@@ -16165,7 +16168,7 @@
           <p:nvPr/>
         </p:nvPicPr>
         <p:blipFill>
-          <a:blip xmlns:r="http://schemas.openxmlformats.org/officeDocument/2006/relationships" xmlns:a="http://schemas.openxmlformats.org/drawingml/2006/main" r:embed="Rd760871ebb414083"/>
+          <a:blip xmlns:r="http://schemas.openxmlformats.org/officeDocument/2006/relationships" xmlns:a="http://schemas.openxmlformats.org/drawingml/2006/main" r:embed="R49036194a2b44428"/>
           <a:stretch xmlns:a="http://schemas.openxmlformats.org/drawingml/2006/main">
             <a:fillRect l="0" t="0" r="0" b="0"/>
           </a:stretch>
@@ -16189,7 +16192,7 @@
           <p:nvPr/>
         </p:nvPicPr>
         <p:blipFill>
-          <a:blip xmlns:r="http://schemas.openxmlformats.org/officeDocument/2006/relationships" xmlns:a="http://schemas.openxmlformats.org/drawingml/2006/main" r:embed="Ra52e3581ec504ef5"/>
+          <a:blip xmlns:r="http://schemas.openxmlformats.org/officeDocument/2006/relationships" xmlns:a="http://schemas.openxmlformats.org/drawingml/2006/main" r:embed="Ra4378c05aa364ba0"/>
           <a:stretch xmlns:a="http://schemas.openxmlformats.org/drawingml/2006/main">
             <a:fillRect l="0" t="0" r="0" b="0"/>
           </a:stretch>
@@ -16213,7 +16216,7 @@
           <p:nvPr/>
         </p:nvPicPr>
         <p:blipFill>
-          <a:blip xmlns:r="http://schemas.openxmlformats.org/officeDocument/2006/relationships" xmlns:a="http://schemas.openxmlformats.org/drawingml/2006/main" r:embed="R4136bbcd052e4483"/>
+          <a:blip xmlns:r="http://schemas.openxmlformats.org/officeDocument/2006/relationships" xmlns:a="http://schemas.openxmlformats.org/drawingml/2006/main" r:embed="Rec8b968461764a89"/>
           <a:stretch xmlns:a="http://schemas.openxmlformats.org/drawingml/2006/main">
             <a:fillRect l="0" t="0" r="0" b="0"/>
           </a:stretch>
@@ -17197,7 +17200,7 @@
           <p:nvPr/>
         </p:nvPicPr>
         <p:blipFill>
-          <a:blip xmlns:r="http://schemas.openxmlformats.org/officeDocument/2006/relationships" xmlns:a="http://schemas.openxmlformats.org/drawingml/2006/main" r:embed="Rb12f9243ab7f474d"/>
+          <a:blip xmlns:r="http://schemas.openxmlformats.org/officeDocument/2006/relationships" xmlns:a="http://schemas.openxmlformats.org/drawingml/2006/main" r:embed="R3a48f74c272d4263"/>
           <a:stretch xmlns:a="http://schemas.openxmlformats.org/drawingml/2006/main">
             <a:fillRect l="0" t="0" r="0" b="0"/>
           </a:stretch>
@@ -17221,7 +17224,7 @@
           <p:nvPr/>
         </p:nvPicPr>
         <p:blipFill>
-          <a:blip xmlns:r="http://schemas.openxmlformats.org/officeDocument/2006/relationships" xmlns:a="http://schemas.openxmlformats.org/drawingml/2006/main" r:embed="R9ba6ba8abc324987"/>
+          <a:blip xmlns:r="http://schemas.openxmlformats.org/officeDocument/2006/relationships" xmlns:a="http://schemas.openxmlformats.org/drawingml/2006/main" r:embed="R3b031277140a45cd"/>
           <a:stretch xmlns:a="http://schemas.openxmlformats.org/drawingml/2006/main">
             <a:fillRect l="0" t="0" r="0" b="0"/>
           </a:stretch>
@@ -17245,7 +17248,7 @@
           <p:nvPr/>
         </p:nvPicPr>
         <p:blipFill>
-          <a:blip xmlns:r="http://schemas.openxmlformats.org/officeDocument/2006/relationships" xmlns:a="http://schemas.openxmlformats.org/drawingml/2006/main" r:embed="Rcbcc74426d5845a4"/>
+          <a:blip xmlns:r="http://schemas.openxmlformats.org/officeDocument/2006/relationships" xmlns:a="http://schemas.openxmlformats.org/drawingml/2006/main" r:embed="R7816002465634a3b"/>
           <a:stretch xmlns:a="http://schemas.openxmlformats.org/drawingml/2006/main">
             <a:fillRect l="0" t="0" r="0" b="0"/>
           </a:stretch>
@@ -17269,7 +17272,7 @@
           <p:nvPr/>
         </p:nvPicPr>
         <p:blipFill>
-          <a:blip xmlns:r="http://schemas.openxmlformats.org/officeDocument/2006/relationships" xmlns:a="http://schemas.openxmlformats.org/drawingml/2006/main" r:embed="Rc4a6943114dc4b27"/>
+          <a:blip xmlns:r="http://schemas.openxmlformats.org/officeDocument/2006/relationships" xmlns:a="http://schemas.openxmlformats.org/drawingml/2006/main" r:embed="R7528bb675015426f"/>
           <a:stretch xmlns:a="http://schemas.openxmlformats.org/drawingml/2006/main">
             <a:fillRect l="0" t="0" r="0" b="0"/>
           </a:stretch>
@@ -18029,7 +18032,7 @@
           <p:nvPr/>
         </p:nvPicPr>
         <p:blipFill>
-          <a:blip xmlns:r="http://schemas.openxmlformats.org/officeDocument/2006/relationships" xmlns:a="http://schemas.openxmlformats.org/drawingml/2006/main" r:embed="Rcf2b071378a04ed8"/>
+          <a:blip xmlns:r="http://schemas.openxmlformats.org/officeDocument/2006/relationships" xmlns:a="http://schemas.openxmlformats.org/drawingml/2006/main" r:embed="R83985813a8da4980"/>
           <a:stretch xmlns:a="http://schemas.openxmlformats.org/drawingml/2006/main">
             <a:fillRect l="0" t="0" r="0" b="0"/>
           </a:stretch>
@@ -18053,7 +18056,7 @@
           <p:nvPr/>
         </p:nvPicPr>
         <p:blipFill>
-          <a:blip xmlns:r="http://schemas.openxmlformats.org/officeDocument/2006/relationships" xmlns:a="http://schemas.openxmlformats.org/drawingml/2006/main" r:embed="R6a5c882278614373"/>
+          <a:blip xmlns:r="http://schemas.openxmlformats.org/officeDocument/2006/relationships" xmlns:a="http://schemas.openxmlformats.org/drawingml/2006/main" r:embed="Rf6897735faca4b29"/>
           <a:stretch xmlns:a="http://schemas.openxmlformats.org/drawingml/2006/main">
             <a:fillRect l="0" t="0" r="0" b="0"/>
           </a:stretch>
@@ -18077,7 +18080,7 @@
           <p:nvPr/>
         </p:nvPicPr>
         <p:blipFill>
-          <a:blip xmlns:r="http://schemas.openxmlformats.org/officeDocument/2006/relationships" xmlns:a="http://schemas.openxmlformats.org/drawingml/2006/main" r:embed="Rdb0dcb3ef5c449b3"/>
+          <a:blip xmlns:r="http://schemas.openxmlformats.org/officeDocument/2006/relationships" xmlns:a="http://schemas.openxmlformats.org/drawingml/2006/main" r:embed="Rd1c13f6d0032456c"/>
           <a:stretch xmlns:a="http://schemas.openxmlformats.org/drawingml/2006/main">
             <a:fillRect l="0" t="0" r="0" b="0"/>
           </a:stretch>
@@ -18101,7 +18104,7 @@
           <p:nvPr/>
         </p:nvPicPr>
         <p:blipFill>
-          <a:blip xmlns:r="http://schemas.openxmlformats.org/officeDocument/2006/relationships" xmlns:a="http://schemas.openxmlformats.org/drawingml/2006/main" r:embed="R11f4b94e06134652"/>
+          <a:blip xmlns:r="http://schemas.openxmlformats.org/officeDocument/2006/relationships" xmlns:a="http://schemas.openxmlformats.org/drawingml/2006/main" r:embed="Rf677d4c803da4a09"/>
           <a:stretch xmlns:a="http://schemas.openxmlformats.org/drawingml/2006/main">
             <a:fillRect l="0" t="0" r="0" b="0"/>
           </a:stretch>
@@ -19220,7 +19223,7 @@
           <p:nvPr/>
         </p:nvPicPr>
         <p:blipFill>
-          <a:blip xmlns:r="http://schemas.openxmlformats.org/officeDocument/2006/relationships" xmlns:a="http://schemas.openxmlformats.org/drawingml/2006/main" r:embed="R761c7b8b478b41b5"/>
+          <a:blip xmlns:r="http://schemas.openxmlformats.org/officeDocument/2006/relationships" xmlns:a="http://schemas.openxmlformats.org/drawingml/2006/main" r:embed="Re03c378c62074b4c"/>
           <a:stretch xmlns:a="http://schemas.openxmlformats.org/drawingml/2006/main">
             <a:fillRect l="0" t="0" r="0" b="0"/>
           </a:stretch>
@@ -19333,7 +19336,7 @@
           <p:nvPr/>
         </p:nvPicPr>
         <p:blipFill>
-          <a:blip xmlns:r="http://schemas.openxmlformats.org/officeDocument/2006/relationships" xmlns:a="http://schemas.openxmlformats.org/drawingml/2006/main" r:embed="Rdb8495f113d041ae"/>
+          <a:blip xmlns:r="http://schemas.openxmlformats.org/officeDocument/2006/relationships" xmlns:a="http://schemas.openxmlformats.org/drawingml/2006/main" r:embed="Rab651b9abe4c49da"/>
           <a:stretch xmlns:a="http://schemas.openxmlformats.org/drawingml/2006/main">
             <a:fillRect l="0" t="0" r="0" b="0"/>
           </a:stretch>
@@ -19357,7 +19360,7 @@
           <p:nvPr/>
         </p:nvPicPr>
         <p:blipFill>
-          <a:blip xmlns:r="http://schemas.openxmlformats.org/officeDocument/2006/relationships" xmlns:a="http://schemas.openxmlformats.org/drawingml/2006/main" r:embed="R654c4da73f264532"/>
+          <a:blip xmlns:r="http://schemas.openxmlformats.org/officeDocument/2006/relationships" xmlns:a="http://schemas.openxmlformats.org/drawingml/2006/main" r:embed="R0ab2d439d84d4ba7"/>
           <a:stretch xmlns:a="http://schemas.openxmlformats.org/drawingml/2006/main">
             <a:fillRect l="0" t="0" r="0" b="0"/>
           </a:stretch>
@@ -19381,7 +19384,7 @@
           <p:nvPr/>
         </p:nvPicPr>
         <p:blipFill>
-          <a:blip xmlns:r="http://schemas.openxmlformats.org/officeDocument/2006/relationships" xmlns:a="http://schemas.openxmlformats.org/drawingml/2006/main" r:embed="R44950ee01f144154"/>
+          <a:blip xmlns:r="http://schemas.openxmlformats.org/officeDocument/2006/relationships" xmlns:a="http://schemas.openxmlformats.org/drawingml/2006/main" r:embed="Racfd03b9bdd844fe"/>
           <a:stretch xmlns:a="http://schemas.openxmlformats.org/drawingml/2006/main">
             <a:fillRect l="0" t="0" r="0" b="0"/>
           </a:stretch>
@@ -19405,7 +19408,7 @@
           <p:nvPr/>
         </p:nvPicPr>
         <p:blipFill>
-          <a:blip xmlns:r="http://schemas.openxmlformats.org/officeDocument/2006/relationships" xmlns:a="http://schemas.openxmlformats.org/drawingml/2006/main" r:embed="R64af5e0c139d4628"/>
+          <a:blip xmlns:r="http://schemas.openxmlformats.org/officeDocument/2006/relationships" xmlns:a="http://schemas.openxmlformats.org/drawingml/2006/main" r:embed="R5b33fd9958704f28"/>
           <a:stretch xmlns:a="http://schemas.openxmlformats.org/drawingml/2006/main">
             <a:fillRect l="0" t="0" r="0" b="0"/>
           </a:stretch>
@@ -19451,7 +19454,7 @@
           <p:nvPr/>
         </p:nvPicPr>
         <p:blipFill>
-          <a:blip xmlns:r="http://schemas.openxmlformats.org/officeDocument/2006/relationships" xmlns:a="http://schemas.openxmlformats.org/drawingml/2006/main" r:embed="Rcdd1040f80014e97"/>
+          <a:blip xmlns:r="http://schemas.openxmlformats.org/officeDocument/2006/relationships" xmlns:a="http://schemas.openxmlformats.org/drawingml/2006/main" r:embed="R801f66c4b17b4208"/>
           <a:stretch xmlns:a="http://schemas.openxmlformats.org/drawingml/2006/main">
             <a:fillRect l="0" t="0" r="0" b="0"/>
           </a:stretch>
@@ -19475,7 +19478,7 @@
           <p:nvPr/>
         </p:nvPicPr>
         <p:blipFill>
-          <a:blip xmlns:r="http://schemas.openxmlformats.org/officeDocument/2006/relationships" xmlns:a="http://schemas.openxmlformats.org/drawingml/2006/main" r:embed="R5adcfb04afa248d9"/>
+          <a:blip xmlns:r="http://schemas.openxmlformats.org/officeDocument/2006/relationships" xmlns:a="http://schemas.openxmlformats.org/drawingml/2006/main" r:embed="R85aad63ca6314eff"/>
           <a:stretch xmlns:a="http://schemas.openxmlformats.org/drawingml/2006/main">
             <a:fillRect l="0" t="0" r="0" b="0"/>
           </a:stretch>
@@ -19499,7 +19502,7 @@
           <p:nvPr/>
         </p:nvPicPr>
         <p:blipFill>
-          <a:blip xmlns:r="http://schemas.openxmlformats.org/officeDocument/2006/relationships" xmlns:a="http://schemas.openxmlformats.org/drawingml/2006/main" r:embed="R3af2859e67ad4e04"/>
+          <a:blip xmlns:r="http://schemas.openxmlformats.org/officeDocument/2006/relationships" xmlns:a="http://schemas.openxmlformats.org/drawingml/2006/main" r:embed="R58d14a44d3a84acb"/>
           <a:stretch xmlns:a="http://schemas.openxmlformats.org/drawingml/2006/main">
             <a:fillRect l="0" t="0" r="0" b="0"/>
           </a:stretch>
@@ -19523,7 +19526,7 @@
           <p:nvPr/>
         </p:nvPicPr>
         <p:blipFill>
-          <a:blip xmlns:r="http://schemas.openxmlformats.org/officeDocument/2006/relationships" xmlns:a="http://schemas.openxmlformats.org/drawingml/2006/main" r:embed="Rd05ee2495d934cb8"/>
+          <a:blip xmlns:r="http://schemas.openxmlformats.org/officeDocument/2006/relationships" xmlns:a="http://schemas.openxmlformats.org/drawingml/2006/main" r:embed="Rb0b45219da21411a"/>
           <a:stretch xmlns:a="http://schemas.openxmlformats.org/drawingml/2006/main">
             <a:fillRect l="0" t="0" r="0" b="0"/>
           </a:stretch>
@@ -20227,7 +20230,7 @@
           <p:nvPr/>
         </p:nvPicPr>
         <p:blipFill>
-          <a:blip xmlns:r="http://schemas.openxmlformats.org/officeDocument/2006/relationships" xmlns:a="http://schemas.openxmlformats.org/drawingml/2006/main" r:embed="Rd81ae71a32204f54"/>
+          <a:blip xmlns:r="http://schemas.openxmlformats.org/officeDocument/2006/relationships" xmlns:a="http://schemas.openxmlformats.org/drawingml/2006/main" r:embed="Rcb411be788dd4bad"/>
           <a:stretch xmlns:a="http://schemas.openxmlformats.org/drawingml/2006/main">
             <a:fillRect l="0" t="0" r="0" b="0"/>
           </a:stretch>
@@ -20251,7 +20254,7 @@
           <p:nvPr/>
         </p:nvPicPr>
         <p:blipFill>
-          <a:blip xmlns:r="http://schemas.openxmlformats.org/officeDocument/2006/relationships" xmlns:a="http://schemas.openxmlformats.org/drawingml/2006/main" r:embed="Rf1b175507bba4116"/>
+          <a:blip xmlns:r="http://schemas.openxmlformats.org/officeDocument/2006/relationships" xmlns:a="http://schemas.openxmlformats.org/drawingml/2006/main" r:embed="Rea8ceb7a70de40a6"/>
           <a:stretch xmlns:a="http://schemas.openxmlformats.org/drawingml/2006/main">
             <a:fillRect l="0" t="0" r="0" b="0"/>
           </a:stretch>
@@ -20275,7 +20278,7 @@
           <p:nvPr/>
         </p:nvPicPr>
         <p:blipFill>
-          <a:blip xmlns:r="http://schemas.openxmlformats.org/officeDocument/2006/relationships" xmlns:a="http://schemas.openxmlformats.org/drawingml/2006/main" r:embed="Rfb3c700968f348ad"/>
+          <a:blip xmlns:r="http://schemas.openxmlformats.org/officeDocument/2006/relationships" xmlns:a="http://schemas.openxmlformats.org/drawingml/2006/main" r:embed="Ra47dd033df8a40c8"/>
           <a:stretch xmlns:a="http://schemas.openxmlformats.org/drawingml/2006/main">
             <a:fillRect l="0" t="0" r="0" b="0"/>
           </a:stretch>
@@ -20299,7 +20302,7 @@
           <p:nvPr/>
         </p:nvPicPr>
         <p:blipFill>
-          <a:blip xmlns:r="http://schemas.openxmlformats.org/officeDocument/2006/relationships" xmlns:a="http://schemas.openxmlformats.org/drawingml/2006/main" r:embed="R20952fe062464310"/>
+          <a:blip xmlns:r="http://schemas.openxmlformats.org/officeDocument/2006/relationships" xmlns:a="http://schemas.openxmlformats.org/drawingml/2006/main" r:embed="R6aab91e511d7418c"/>
           <a:stretch xmlns:a="http://schemas.openxmlformats.org/drawingml/2006/main">
             <a:fillRect l="0" t="0" r="0" b="0"/>
           </a:stretch>
@@ -21187,7 +21190,7 @@
           <p:nvPr/>
         </p:nvPicPr>
         <p:blipFill>
-          <a:blip xmlns:r="http://schemas.openxmlformats.org/officeDocument/2006/relationships" xmlns:a="http://schemas.openxmlformats.org/drawingml/2006/main" r:embed="Rba6ab3b99e83448d"/>
+          <a:blip xmlns:r="http://schemas.openxmlformats.org/officeDocument/2006/relationships" xmlns:a="http://schemas.openxmlformats.org/drawingml/2006/main" r:embed="R41bee278d9d64355"/>
           <a:stretch xmlns:a="http://schemas.openxmlformats.org/drawingml/2006/main">
             <a:fillRect l="0" t="0" r="0" b="0"/>
           </a:stretch>
@@ -21211,7 +21214,7 @@
           <p:nvPr/>
         </p:nvPicPr>
         <p:blipFill>
-          <a:blip xmlns:r="http://schemas.openxmlformats.org/officeDocument/2006/relationships" xmlns:a="http://schemas.openxmlformats.org/drawingml/2006/main" r:embed="R2a5f67e429c945ae"/>
+          <a:blip xmlns:r="http://schemas.openxmlformats.org/officeDocument/2006/relationships" xmlns:a="http://schemas.openxmlformats.org/drawingml/2006/main" r:embed="Ra111ce868d1b4493"/>
           <a:stretch xmlns:a="http://schemas.openxmlformats.org/drawingml/2006/main">
             <a:fillRect l="0" t="0" r="0" b="0"/>
           </a:stretch>
@@ -21235,7 +21238,7 @@
           <p:nvPr/>
         </p:nvPicPr>
         <p:blipFill>
-          <a:blip xmlns:r="http://schemas.openxmlformats.org/officeDocument/2006/relationships" xmlns:a="http://schemas.openxmlformats.org/drawingml/2006/main" r:embed="Rcbe5db33d1aa4526"/>
+          <a:blip xmlns:r="http://schemas.openxmlformats.org/officeDocument/2006/relationships" xmlns:a="http://schemas.openxmlformats.org/drawingml/2006/main" r:embed="R803892daebc14624"/>
           <a:stretch xmlns:a="http://schemas.openxmlformats.org/drawingml/2006/main">
             <a:fillRect l="0" t="0" r="0" b="0"/>
           </a:stretch>
@@ -21259,7 +21262,7 @@
           <p:nvPr/>
         </p:nvPicPr>
         <p:blipFill>
-          <a:blip xmlns:r="http://schemas.openxmlformats.org/officeDocument/2006/relationships" xmlns:a="http://schemas.openxmlformats.org/drawingml/2006/main" r:embed="Re1c2f97160344a49"/>
+          <a:blip xmlns:r="http://schemas.openxmlformats.org/officeDocument/2006/relationships" xmlns:a="http://schemas.openxmlformats.org/drawingml/2006/main" r:embed="R59e7a8e8e7484407"/>
           <a:stretch xmlns:a="http://schemas.openxmlformats.org/drawingml/2006/main">
             <a:fillRect l="0" t="0" r="0" b="0"/>
           </a:stretch>
@@ -21844,7 +21847,7 @@
           <p:nvPr/>
         </p:nvPicPr>
         <p:blipFill>
-          <a:blip xmlns:r="http://schemas.openxmlformats.org/officeDocument/2006/relationships" xmlns:a="http://schemas.openxmlformats.org/drawingml/2006/main" r:embed="R535e31b0c6d048d3"/>
+          <a:blip xmlns:r="http://schemas.openxmlformats.org/officeDocument/2006/relationships" xmlns:a="http://schemas.openxmlformats.org/drawingml/2006/main" r:embed="R975ebaf8c2df4923"/>
           <a:stretch xmlns:a="http://schemas.openxmlformats.org/drawingml/2006/main">
             <a:fillRect l="0" t="0" r="0" b="0"/>
           </a:stretch>
@@ -21868,7 +21871,7 @@
           <p:nvPr/>
         </p:nvPicPr>
         <p:blipFill>
-          <a:blip xmlns:r="http://schemas.openxmlformats.org/officeDocument/2006/relationships" xmlns:a="http://schemas.openxmlformats.org/drawingml/2006/main" r:embed="R2a549fee40c64d4d"/>
+          <a:blip xmlns:r="http://schemas.openxmlformats.org/officeDocument/2006/relationships" xmlns:a="http://schemas.openxmlformats.org/drawingml/2006/main" r:embed="R0c49fa340dd84757"/>
           <a:stretch xmlns:a="http://schemas.openxmlformats.org/drawingml/2006/main">
             <a:fillRect l="0" t="0" r="0" b="0"/>
           </a:stretch>
@@ -21892,7 +21895,7 @@
           <p:nvPr/>
         </p:nvPicPr>
         <p:blipFill>
-          <a:blip xmlns:r="http://schemas.openxmlformats.org/officeDocument/2006/relationships" xmlns:a="http://schemas.openxmlformats.org/drawingml/2006/main" r:embed="Rc3ce3021b1a34783"/>
+          <a:blip xmlns:r="http://schemas.openxmlformats.org/officeDocument/2006/relationships" xmlns:a="http://schemas.openxmlformats.org/drawingml/2006/main" r:embed="R5caf97d8117346d3"/>
           <a:stretch xmlns:a="http://schemas.openxmlformats.org/drawingml/2006/main">
             <a:fillRect l="0" t="0" r="0" b="0"/>
           </a:stretch>
@@ -21916,7 +21919,7 @@
           <p:nvPr/>
         </p:nvPicPr>
         <p:blipFill>
-          <a:blip xmlns:r="http://schemas.openxmlformats.org/officeDocument/2006/relationships" xmlns:a="http://schemas.openxmlformats.org/drawingml/2006/main" r:embed="Ra4df9195df6f4ee7"/>
+          <a:blip xmlns:r="http://schemas.openxmlformats.org/officeDocument/2006/relationships" xmlns:a="http://schemas.openxmlformats.org/drawingml/2006/main" r:embed="Rd64fdf3d59e142e1"/>
           <a:stretch xmlns:a="http://schemas.openxmlformats.org/drawingml/2006/main">
             <a:fillRect l="0" t="0" r="0" b="0"/>
           </a:stretch>
@@ -22623,7 +22626,7 @@
           <p:nvPr/>
         </p:nvPicPr>
         <p:blipFill>
-          <a:blip xmlns:r="http://schemas.openxmlformats.org/officeDocument/2006/relationships" xmlns:a="http://schemas.openxmlformats.org/drawingml/2006/main" r:embed="Re6c2698daf924c63"/>
+          <a:blip xmlns:r="http://schemas.openxmlformats.org/officeDocument/2006/relationships" xmlns:a="http://schemas.openxmlformats.org/drawingml/2006/main" r:embed="R71691cddcb114f79"/>
           <a:stretch xmlns:a="http://schemas.openxmlformats.org/drawingml/2006/main">
             <a:fillRect l="0" t="0" r="0" b="0"/>
           </a:stretch>
@@ -22647,7 +22650,7 @@
           <p:nvPr/>
         </p:nvPicPr>
         <p:blipFill>
-          <a:blip xmlns:r="http://schemas.openxmlformats.org/officeDocument/2006/relationships" xmlns:a="http://schemas.openxmlformats.org/drawingml/2006/main" r:embed="Ra4bb3d6aeba845f0"/>
+          <a:blip xmlns:r="http://schemas.openxmlformats.org/officeDocument/2006/relationships" xmlns:a="http://schemas.openxmlformats.org/drawingml/2006/main" r:embed="R5e8dbc8c4db14591"/>
           <a:stretch xmlns:a="http://schemas.openxmlformats.org/drawingml/2006/main">
             <a:fillRect l="0" t="0" r="0" b="0"/>
           </a:stretch>
@@ -22671,7 +22674,7 @@
           <p:nvPr/>
         </p:nvPicPr>
         <p:blipFill>
-          <a:blip xmlns:r="http://schemas.openxmlformats.org/officeDocument/2006/relationships" xmlns:a="http://schemas.openxmlformats.org/drawingml/2006/main" r:embed="Rc12c49834f79455c"/>
+          <a:blip xmlns:r="http://schemas.openxmlformats.org/officeDocument/2006/relationships" xmlns:a="http://schemas.openxmlformats.org/drawingml/2006/main" r:embed="Rd1c08aa8f90443af"/>
           <a:stretch xmlns:a="http://schemas.openxmlformats.org/drawingml/2006/main">
             <a:fillRect l="0" t="0" r="0" b="0"/>
           </a:stretch>
@@ -22695,7 +22698,7 @@
           <p:nvPr/>
         </p:nvPicPr>
         <p:blipFill>
-          <a:blip xmlns:r="http://schemas.openxmlformats.org/officeDocument/2006/relationships" xmlns:a="http://schemas.openxmlformats.org/drawingml/2006/main" r:embed="R8394f726a05642eb"/>
+          <a:blip xmlns:r="http://schemas.openxmlformats.org/officeDocument/2006/relationships" xmlns:a="http://schemas.openxmlformats.org/drawingml/2006/main" r:embed="R5ed2fce78f844adc"/>
           <a:stretch xmlns:a="http://schemas.openxmlformats.org/drawingml/2006/main">
             <a:fillRect l="0" t="0" r="0" b="0"/>
           </a:stretch>
@@ -24326,7 +24329,7 @@
           <p:nvPr/>
         </p:nvPicPr>
         <p:blipFill>
-          <a:blip xmlns:r="http://schemas.openxmlformats.org/officeDocument/2006/relationships" xmlns:a="http://schemas.openxmlformats.org/drawingml/2006/main" r:embed="Rb297e1efd033484e"/>
+          <a:blip xmlns:r="http://schemas.openxmlformats.org/officeDocument/2006/relationships" xmlns:a="http://schemas.openxmlformats.org/drawingml/2006/main" r:embed="R5e477bf72a5740dd"/>
           <a:stretch xmlns:a="http://schemas.openxmlformats.org/drawingml/2006/main">
             <a:fillRect l="0" t="0" r="0" b="0"/>
           </a:stretch>
@@ -24350,7 +24353,7 @@
           <p:nvPr/>
         </p:nvPicPr>
         <p:blipFill>
-          <a:blip xmlns:r="http://schemas.openxmlformats.org/officeDocument/2006/relationships" xmlns:a="http://schemas.openxmlformats.org/drawingml/2006/main" r:embed="Rc24067ede0d1421a"/>
+          <a:blip xmlns:r="http://schemas.openxmlformats.org/officeDocument/2006/relationships" xmlns:a="http://schemas.openxmlformats.org/drawingml/2006/main" r:embed="R80f9a72cb6aa41d9"/>
           <a:stretch xmlns:a="http://schemas.openxmlformats.org/drawingml/2006/main">
             <a:fillRect l="0" t="0" r="0" b="0"/>
           </a:stretch>
@@ -24374,7 +24377,7 @@
           <p:nvPr/>
         </p:nvPicPr>
         <p:blipFill>
-          <a:blip xmlns:r="http://schemas.openxmlformats.org/officeDocument/2006/relationships" xmlns:a="http://schemas.openxmlformats.org/drawingml/2006/main" r:embed="R0c71fb838b3c4350"/>
+          <a:blip xmlns:r="http://schemas.openxmlformats.org/officeDocument/2006/relationships" xmlns:a="http://schemas.openxmlformats.org/drawingml/2006/main" r:embed="R8b97e7ac63734335"/>
           <a:stretch xmlns:a="http://schemas.openxmlformats.org/drawingml/2006/main">
             <a:fillRect l="0" t="0" r="0" b="0"/>
           </a:stretch>
@@ -24398,7 +24401,7 @@
           <p:nvPr/>
         </p:nvPicPr>
         <p:blipFill>
-          <a:blip xmlns:r="http://schemas.openxmlformats.org/officeDocument/2006/relationships" xmlns:a="http://schemas.openxmlformats.org/drawingml/2006/main" r:embed="Reb90a59001b74170"/>
+          <a:blip xmlns:r="http://schemas.openxmlformats.org/officeDocument/2006/relationships" xmlns:a="http://schemas.openxmlformats.org/drawingml/2006/main" r:embed="Rd86da35b9157409f"/>
           <a:stretch xmlns:a="http://schemas.openxmlformats.org/drawingml/2006/main">
             <a:fillRect l="0" t="0" r="0" b="0"/>
           </a:stretch>
@@ -25275,7 +25278,7 @@
           <p:nvPr/>
         </p:nvPicPr>
         <p:blipFill>
-          <a:blip xmlns:r="http://schemas.openxmlformats.org/officeDocument/2006/relationships" xmlns:a="http://schemas.openxmlformats.org/drawingml/2006/main" r:embed="R5c9482577d254b71"/>
+          <a:blip xmlns:r="http://schemas.openxmlformats.org/officeDocument/2006/relationships" xmlns:a="http://schemas.openxmlformats.org/drawingml/2006/main" r:embed="R1e1ad85331374679"/>
           <a:stretch xmlns:a="http://schemas.openxmlformats.org/drawingml/2006/main">
             <a:fillRect l="0" t="0" r="0" b="0"/>
           </a:stretch>
@@ -25299,7 +25302,7 @@
           <p:nvPr/>
         </p:nvPicPr>
         <p:blipFill>
-          <a:blip xmlns:r="http://schemas.openxmlformats.org/officeDocument/2006/relationships" xmlns:a="http://schemas.openxmlformats.org/drawingml/2006/main" r:embed="R6bbb152b0e654d3c"/>
+          <a:blip xmlns:r="http://schemas.openxmlformats.org/officeDocument/2006/relationships" xmlns:a="http://schemas.openxmlformats.org/drawingml/2006/main" r:embed="R629fa8bf08ae4e78"/>
           <a:stretch xmlns:a="http://schemas.openxmlformats.org/drawingml/2006/main">
             <a:fillRect l="0" t="0" r="0" b="0"/>
           </a:stretch>
@@ -25323,7 +25326,7 @@
           <p:nvPr/>
         </p:nvPicPr>
         <p:blipFill>
-          <a:blip xmlns:r="http://schemas.openxmlformats.org/officeDocument/2006/relationships" xmlns:a="http://schemas.openxmlformats.org/drawingml/2006/main" r:embed="R6e6d35a5e7db4b80"/>
+          <a:blip xmlns:r="http://schemas.openxmlformats.org/officeDocument/2006/relationships" xmlns:a="http://schemas.openxmlformats.org/drawingml/2006/main" r:embed="R075e48460ded4714"/>
           <a:stretch xmlns:a="http://schemas.openxmlformats.org/drawingml/2006/main">
             <a:fillRect l="0" t="0" r="0" b="0"/>
           </a:stretch>
@@ -25347,7 +25350,7 @@
           <p:nvPr/>
         </p:nvPicPr>
         <p:blipFill>
-          <a:blip xmlns:r="http://schemas.openxmlformats.org/officeDocument/2006/relationships" xmlns:a="http://schemas.openxmlformats.org/drawingml/2006/main" r:embed="R3dd9dc1b2bdf4614"/>
+          <a:blip xmlns:r="http://schemas.openxmlformats.org/officeDocument/2006/relationships" xmlns:a="http://schemas.openxmlformats.org/drawingml/2006/main" r:embed="R0fe801a127d5476c"/>
           <a:stretch xmlns:a="http://schemas.openxmlformats.org/drawingml/2006/main">
             <a:fillRect l="0" t="0" r="0" b="0"/>
           </a:stretch>

</xml_diff>